<commit_message>
feat: finalize UI polish and prepare for final presentation
</commit_message>
<xml_diff>
--- a/SmartInterview_Progressive_Updates/04_Presentation_and_Defense/SmartInterview_Project_Presentation_v2.pptx
+++ b/SmartInterview_Progressive_Updates/04_Presentation_and_Defense/SmartInterview_Project_Presentation_v2.pptx
@@ -8,7 +8,6 @@
     <p:notesMasterId r:id="rId12"/>
   </p:notesMasterIdLst>
   <p:sldIdLst>
-    <p:sldId id="318" r:id="rId2"/>
     <p:sldId id="257" r:id="rId3"/>
     <p:sldId id="258" r:id="rId4"/>
     <p:sldId id="323" r:id="rId5"/>
@@ -472,90 +471,6 @@
     </a:lvl9pPr>
   </p:notesStyle>
 </p:notesMaster>
-</file>
-
-<file path=ppt/notesSlides/notesSlide1.xml><?xml version="1.0" encoding="utf-8"?>
-<p:notes xmlns:a="http://schemas.openxmlformats.org/drawingml/2006/main" xmlns:r="http://schemas.openxmlformats.org/officeDocument/2006/relationships" xmlns:p="http://schemas.openxmlformats.org/presentationml/2006/main">
-  <p:cSld>
-    <p:spTree>
-      <p:nvGrpSpPr>
-        <p:cNvPr id="1" name=""/>
-        <p:cNvGrpSpPr/>
-        <p:nvPr/>
-      </p:nvGrpSpPr>
-      <p:grpSpPr>
-        <a:xfrm>
-          <a:off x="0" y="0"/>
-          <a:ext cx="0" cy="0"/>
-          <a:chOff x="0" y="0"/>
-          <a:chExt cx="0" cy="0"/>
-        </a:xfrm>
-      </p:grpSpPr>
-      <p:sp>
-        <p:nvSpPr>
-          <p:cNvPr id="2" name="Slide Image Placeholder 1"/>
-          <p:cNvSpPr>
-            <a:spLocks noGrp="1" noRot="1" noChangeAspect="1"/>
-          </p:cNvSpPr>
-          <p:nvPr>
-            <p:ph type="sldImg"/>
-          </p:nvPr>
-        </p:nvSpPr>
-        <p:spPr/>
-      </p:sp>
-      <p:sp>
-        <p:nvSpPr>
-          <p:cNvPr id="3" name="Notes Placeholder 2"/>
-          <p:cNvSpPr>
-            <a:spLocks noGrp="1"/>
-          </p:cNvSpPr>
-          <p:nvPr>
-            <p:ph type="body" idx="1"/>
-          </p:nvPr>
-        </p:nvSpPr>
-        <p:spPr/>
-        <p:txBody>
-          <a:bodyPr/>
-          <a:lstStyle/>
-          <a:p>
-            <a:endParaRPr lang="en-US" dirty="0"/>
-          </a:p>
-        </p:txBody>
-      </p:sp>
-      <p:sp>
-        <p:nvSpPr>
-          <p:cNvPr id="4" name="Slide Number Placeholder 3"/>
-          <p:cNvSpPr>
-            <a:spLocks noGrp="1"/>
-          </p:cNvSpPr>
-          <p:nvPr>
-            <p:ph type="sldNum" sz="quarter" idx="5"/>
-          </p:nvPr>
-        </p:nvSpPr>
-        <p:spPr/>
-        <p:txBody>
-          <a:bodyPr/>
-          <a:lstStyle/>
-          <a:p>
-            <a:fld id="{323F4ECA-A2DA-4C65-B4BB-80B02CF0864D}" type="slidenum">
-              <a:rPr lang="en-IN" smtClean="0"/>
-              <a:t>1</a:t>
-            </a:fld>
-            <a:endParaRPr lang="en-IN"/>
-          </a:p>
-        </p:txBody>
-      </p:sp>
-    </p:spTree>
-    <p:extLst>
-      <p:ext uri="{BB962C8B-B14F-4D97-AF65-F5344CB8AC3E}">
-        <p14:creationId xmlns:p14="http://schemas.microsoft.com/office/powerpoint/2010/main" val="2843512833"/>
-      </p:ext>
-    </p:extLst>
-  </p:cSld>
-  <p:clrMapOvr>
-    <a:masterClrMapping/>
-  </p:clrMapOvr>
-</p:notes>
 </file>
 
 <file path=ppt/notesSlides/notesSlide2.xml><?xml version="1.0" encoding="utf-8"?>
@@ -9251,521 +9166,6 @@
 </p:sldMaster>
 </file>
 
-<file path=ppt/slides/slide1.xml><?xml version="1.0" encoding="utf-8"?>
-<p:sld xmlns:a="http://schemas.openxmlformats.org/drawingml/2006/main" xmlns:r="http://schemas.openxmlformats.org/officeDocument/2006/relationships" xmlns:p="http://schemas.openxmlformats.org/presentationml/2006/main">
-  <p:cSld>
-    <p:spTree>
-      <p:nvGrpSpPr>
-        <p:cNvPr id="1" name=""/>
-        <p:cNvGrpSpPr/>
-        <p:nvPr/>
-      </p:nvGrpSpPr>
-      <p:grpSpPr>
-        <a:xfrm>
-          <a:off x="0" y="0"/>
-          <a:ext cx="0" cy="0"/>
-          <a:chOff x="0" y="0"/>
-          <a:chExt cx="0" cy="0"/>
-        </a:xfrm>
-      </p:grpSpPr>
-      <p:sp>
-        <p:nvSpPr>
-          <p:cNvPr id="3" name="TextBox 2">
-            <a:extLst>
-              <a:ext uri="{FF2B5EF4-FFF2-40B4-BE49-F238E27FC236}">
-                <a16:creationId xmlns:a16="http://schemas.microsoft.com/office/drawing/2014/main" id="{0B738305-5802-F5B3-D197-C15B1C8AC5E4}"/>
-              </a:ext>
-            </a:extLst>
-          </p:cNvPr>
-          <p:cNvSpPr txBox="1"/>
-          <p:nvPr/>
-        </p:nvSpPr>
-        <p:spPr>
-          <a:xfrm>
-            <a:off x="1101213" y="516190"/>
-            <a:ext cx="10255045" cy="6232988"/>
-          </a:xfrm>
-          <a:prstGeom prst="rect">
-            <a:avLst/>
-          </a:prstGeom>
-          <a:noFill/>
-        </p:spPr>
-        <p:txBody>
-          <a:bodyPr wrap="square">
-            <a:spAutoFit/>
-          </a:bodyPr>
-          <a:lstStyle/>
-          <a:p>
-            <a:pPr>
-              <a:lnSpc>
-                <a:spcPct val="150000"/>
-              </a:lnSpc>
-            </a:pPr>
-            <a:r>
-              <a:rPr lang="en-US" sz="1400" dirty="0">
-                <a:latin typeface="Arial" panose="020B0604020202020204" pitchFamily="34" charset="0"/>
-                <a:cs typeface="Arial" panose="020B0604020202020204" pitchFamily="34" charset="0"/>
-              </a:rPr>
-              <a:t>Dear Students,</a:t>
-            </a:r>
-          </a:p>
-          <a:p>
-            <a:pPr>
-              <a:lnSpc>
-                <a:spcPct val="150000"/>
-              </a:lnSpc>
-            </a:pPr>
-            <a:r>
-              <a:rPr lang="en-US" sz="1400" dirty="0">
-                <a:latin typeface="Arial" panose="020B0604020202020204" pitchFamily="34" charset="0"/>
-                <a:cs typeface="Arial" panose="020B0604020202020204" pitchFamily="34" charset="0"/>
-              </a:rPr>
-              <a:t>Please adhere to the following guidelines for your project presentations: </a:t>
-            </a:r>
-            <a:r>
-              <a:rPr lang="en-US" sz="1400" b="1" dirty="0">
-                <a:latin typeface="Arial" panose="020B0604020202020204" pitchFamily="34" charset="0"/>
-                <a:cs typeface="Arial" panose="020B0604020202020204" pitchFamily="34" charset="0"/>
-              </a:rPr>
-              <a:t>Presentation Guidelines</a:t>
-            </a:r>
-          </a:p>
-          <a:p>
-            <a:pPr>
-              <a:lnSpc>
-                <a:spcPct val="150000"/>
-              </a:lnSpc>
-              <a:buFont typeface="+mj-lt"/>
-              <a:buAutoNum type="arabicPeriod"/>
-            </a:pPr>
-            <a:r>
-              <a:rPr lang="en-US" sz="1400" b="1" dirty="0">
-                <a:latin typeface="Arial" panose="020B0604020202020204" pitchFamily="34" charset="0"/>
-                <a:cs typeface="Arial" panose="020B0604020202020204" pitchFamily="34" charset="0"/>
-              </a:rPr>
-              <a:t>Slide Limit:</a:t>
-            </a:r>
-            <a:endParaRPr lang="en-US" sz="1400" dirty="0">
-              <a:latin typeface="Arial" panose="020B0604020202020204" pitchFamily="34" charset="0"/>
-              <a:cs typeface="Arial" panose="020B0604020202020204" pitchFamily="34" charset="0"/>
-            </a:endParaRPr>
-          </a:p>
-          <a:p>
-            <a:pPr marL="742950" lvl="1" indent="-285750">
-              <a:lnSpc>
-                <a:spcPct val="150000"/>
-              </a:lnSpc>
-              <a:buFont typeface="+mj-lt"/>
-              <a:buAutoNum type="arabicPeriod"/>
-            </a:pPr>
-            <a:r>
-              <a:rPr lang="en-US" sz="1400" dirty="0">
-                <a:latin typeface="Arial" panose="020B0604020202020204" pitchFamily="34" charset="0"/>
-                <a:cs typeface="Arial" panose="020B0604020202020204" pitchFamily="34" charset="0"/>
-              </a:rPr>
-              <a:t>Maximum </a:t>
-            </a:r>
-            <a:r>
-              <a:rPr lang="en-US" sz="1400" b="1" dirty="0">
-                <a:latin typeface="Arial" panose="020B0604020202020204" pitchFamily="34" charset="0"/>
-                <a:cs typeface="Arial" panose="020B0604020202020204" pitchFamily="34" charset="0"/>
-              </a:rPr>
-              <a:t>6-7 slides</a:t>
-            </a:r>
-            <a:r>
-              <a:rPr lang="en-US" sz="1400" dirty="0">
-                <a:latin typeface="Arial" panose="020B0604020202020204" pitchFamily="34" charset="0"/>
-                <a:cs typeface="Arial" panose="020B0604020202020204" pitchFamily="34" charset="0"/>
-              </a:rPr>
-              <a:t>. Other than Title Slide (1</a:t>
-            </a:r>
-            <a:r>
-              <a:rPr lang="en-US" sz="1400" baseline="30000" dirty="0">
-                <a:latin typeface="Arial" panose="020B0604020202020204" pitchFamily="34" charset="0"/>
-                <a:cs typeface="Arial" panose="020B0604020202020204" pitchFamily="34" charset="0"/>
-              </a:rPr>
-              <a:t>st</a:t>
-            </a:r>
-            <a:r>
-              <a:rPr lang="en-US" sz="1400" dirty="0">
-                <a:latin typeface="Arial" panose="020B0604020202020204" pitchFamily="34" charset="0"/>
-                <a:cs typeface="Arial" panose="020B0604020202020204" pitchFamily="34" charset="0"/>
-              </a:rPr>
-              <a:t> Slide), Contents Slide (2nd Slide) and Thank you Slide (Last Slide</a:t>
-            </a:r>
-          </a:p>
-          <a:p>
-            <a:pPr>
-              <a:lnSpc>
-                <a:spcPct val="150000"/>
-              </a:lnSpc>
-              <a:buFont typeface="+mj-lt"/>
-              <a:buAutoNum type="arabicPeriod"/>
-            </a:pPr>
-            <a:r>
-              <a:rPr lang="en-US" sz="1400" b="1" dirty="0">
-                <a:latin typeface="Arial" panose="020B0604020202020204" pitchFamily="34" charset="0"/>
-                <a:cs typeface="Arial" panose="020B0604020202020204" pitchFamily="34" charset="0"/>
-              </a:rPr>
-              <a:t>Slide Structure &amp; Suggested Content in each slide: </a:t>
-            </a:r>
-            <a:endParaRPr lang="en-US" sz="1400" dirty="0">
-              <a:latin typeface="Arial" panose="020B0604020202020204" pitchFamily="34" charset="0"/>
-              <a:cs typeface="Arial" panose="020B0604020202020204" pitchFamily="34" charset="0"/>
-            </a:endParaRPr>
-          </a:p>
-          <a:p>
-            <a:pPr lvl="1">
-              <a:lnSpc>
-                <a:spcPct val="150000"/>
-              </a:lnSpc>
-            </a:pPr>
-            <a:r>
-              <a:rPr lang="en-US" sz="1400" b="1" dirty="0">
-                <a:latin typeface="Arial" panose="020B0604020202020204" pitchFamily="34" charset="0"/>
-                <a:cs typeface="Arial" panose="020B0604020202020204" pitchFamily="34" charset="0"/>
-              </a:rPr>
-              <a:t>Slide 1:</a:t>
-            </a:r>
-            <a:r>
-              <a:rPr lang="en-US" sz="1400" dirty="0">
-                <a:latin typeface="Arial" panose="020B0604020202020204" pitchFamily="34" charset="0"/>
-                <a:cs typeface="Arial" panose="020B0604020202020204" pitchFamily="34" charset="0"/>
-              </a:rPr>
-              <a:t> Title (Project # | Project ID | Project Title, Team Members, Mentor Group Members, Date)</a:t>
-            </a:r>
-          </a:p>
-          <a:p>
-            <a:pPr lvl="1">
-              <a:lnSpc>
-                <a:spcPct val="150000"/>
-              </a:lnSpc>
-            </a:pPr>
-            <a:r>
-              <a:rPr lang="en-US" sz="1400" b="1" dirty="0">
-                <a:latin typeface="Arial" panose="020B0604020202020204" pitchFamily="34" charset="0"/>
-                <a:cs typeface="Arial" panose="020B0604020202020204" pitchFamily="34" charset="0"/>
-              </a:rPr>
-              <a:t>Slide 2:</a:t>
-            </a:r>
-            <a:r>
-              <a:rPr lang="en-US" sz="1400" dirty="0">
-                <a:latin typeface="Arial" panose="020B0604020202020204" pitchFamily="34" charset="0"/>
-                <a:cs typeface="Arial" panose="020B0604020202020204" pitchFamily="34" charset="0"/>
-              </a:rPr>
-              <a:t> Contents (List of  the Slides in the PPT in order) </a:t>
-            </a:r>
-          </a:p>
-          <a:p>
-            <a:pPr lvl="1">
-              <a:lnSpc>
-                <a:spcPct val="150000"/>
-              </a:lnSpc>
-            </a:pPr>
-            <a:r>
-              <a:rPr lang="en-US" sz="1400" b="1" dirty="0">
-                <a:latin typeface="Arial" panose="020B0604020202020204" pitchFamily="34" charset="0"/>
-                <a:cs typeface="Arial" panose="020B0604020202020204" pitchFamily="34" charset="0"/>
-              </a:rPr>
-              <a:t>Slide 3:</a:t>
-            </a:r>
-            <a:r>
-              <a:rPr lang="en-US" sz="1400" dirty="0">
-                <a:latin typeface="Arial" panose="020B0604020202020204" pitchFamily="34" charset="0"/>
-                <a:cs typeface="Arial" panose="020B0604020202020204" pitchFamily="34" charset="0"/>
-              </a:rPr>
-              <a:t> Introduction [Brief End user requirement | Abstract/Gist of Problem Statement | Objective(s) (End User Benefit/Solution Impact) | Technology Stack (New Skills Learning)…etc.] | Base Paper Title</a:t>
-            </a:r>
-          </a:p>
-          <a:p>
-            <a:pPr lvl="1">
-              <a:lnSpc>
-                <a:spcPct val="150000"/>
-              </a:lnSpc>
-            </a:pPr>
-            <a:r>
-              <a:rPr lang="en-US" sz="1400" b="1" dirty="0">
-                <a:latin typeface="Arial" panose="020B0604020202020204" pitchFamily="34" charset="0"/>
-                <a:cs typeface="Arial" panose="020B0604020202020204" pitchFamily="34" charset="0"/>
-              </a:rPr>
-              <a:t>Slide 4:</a:t>
-            </a:r>
-            <a:r>
-              <a:rPr lang="en-US" sz="1400" dirty="0">
-                <a:latin typeface="Arial" panose="020B0604020202020204" pitchFamily="34" charset="0"/>
-                <a:cs typeface="Arial" panose="020B0604020202020204" pitchFamily="34" charset="0"/>
-              </a:rPr>
-              <a:t> Requirement: [What is the outcome - Application/Add-on/Any product | Feature List…etc.]</a:t>
-            </a:r>
-          </a:p>
-          <a:p>
-            <a:pPr lvl="1">
-              <a:lnSpc>
-                <a:spcPct val="150000"/>
-              </a:lnSpc>
-            </a:pPr>
-            <a:r>
-              <a:rPr lang="en-US" sz="1400" b="1" dirty="0">
-                <a:latin typeface="Arial" panose="020B0604020202020204" pitchFamily="34" charset="0"/>
-                <a:cs typeface="Arial" panose="020B0604020202020204" pitchFamily="34" charset="0"/>
-              </a:rPr>
-              <a:t>Slide 5:</a:t>
-            </a:r>
-            <a:r>
-              <a:rPr lang="en-US" sz="1400" dirty="0">
-                <a:latin typeface="Arial" panose="020B0604020202020204" pitchFamily="34" charset="0"/>
-                <a:cs typeface="Arial" panose="020B0604020202020204" pitchFamily="34" charset="0"/>
-              </a:rPr>
-              <a:t> Design: [Use Case WF | Solution Design | Architecture Diagram | DB…etc.] </a:t>
-            </a:r>
-            <a:r>
-              <a:rPr lang="en-US" sz="1400" b="1" dirty="0">
-                <a:latin typeface="Arial" panose="020B0604020202020204" pitchFamily="34" charset="0"/>
-                <a:cs typeface="Arial" panose="020B0604020202020204" pitchFamily="34" charset="0"/>
-              </a:rPr>
-              <a:t>(IOT Projects to have equivalent content or as applicable)</a:t>
-            </a:r>
-          </a:p>
-          <a:p>
-            <a:pPr lvl="1">
-              <a:lnSpc>
-                <a:spcPct val="150000"/>
-              </a:lnSpc>
-            </a:pPr>
-            <a:r>
-              <a:rPr lang="en-US" sz="1400" b="1" dirty="0">
-                <a:latin typeface="Arial" panose="020B0604020202020204" pitchFamily="34" charset="0"/>
-                <a:cs typeface="Arial" panose="020B0604020202020204" pitchFamily="34" charset="0"/>
-              </a:rPr>
-              <a:t>Slide 6:</a:t>
-            </a:r>
-            <a:r>
-              <a:rPr lang="en-US" sz="1400" dirty="0">
-                <a:latin typeface="Arial" panose="020B0604020202020204" pitchFamily="34" charset="0"/>
-                <a:cs typeface="Arial" panose="020B0604020202020204" pitchFamily="34" charset="0"/>
-              </a:rPr>
-              <a:t>  Development: Coding | Workflow | Tools used | Test cases | …etc.] </a:t>
-            </a:r>
-            <a:r>
-              <a:rPr lang="en-US" sz="1400" b="1" dirty="0">
-                <a:latin typeface="Arial" panose="020B0604020202020204" pitchFamily="34" charset="0"/>
-                <a:cs typeface="Arial" panose="020B0604020202020204" pitchFamily="34" charset="0"/>
-              </a:rPr>
-              <a:t>(IOT Projects to have equivalent content or as applicable)</a:t>
-            </a:r>
-            <a:endParaRPr lang="en-US" sz="1400" dirty="0">
-              <a:latin typeface="Arial" panose="020B0604020202020204" pitchFamily="34" charset="0"/>
-              <a:cs typeface="Arial" panose="020B0604020202020204" pitchFamily="34" charset="0"/>
-            </a:endParaRPr>
-          </a:p>
-          <a:p>
-            <a:pPr lvl="1">
-              <a:lnSpc>
-                <a:spcPct val="150000"/>
-              </a:lnSpc>
-            </a:pPr>
-            <a:r>
-              <a:rPr lang="en-US" sz="1400" b="1" dirty="0">
-                <a:latin typeface="Arial" panose="020B0604020202020204" pitchFamily="34" charset="0"/>
-                <a:cs typeface="Arial" panose="020B0604020202020204" pitchFamily="34" charset="0"/>
-              </a:rPr>
-              <a:t>Slide 7:</a:t>
-            </a:r>
-            <a:r>
-              <a:rPr lang="en-US" sz="1400" dirty="0">
-                <a:latin typeface="Arial" panose="020B0604020202020204" pitchFamily="34" charset="0"/>
-                <a:cs typeface="Arial" panose="020B0604020202020204" pitchFamily="34" charset="0"/>
-              </a:rPr>
-              <a:t> Project Outcome: [Summary | Improvement Opportunities | Challenges faced | …etc.] [Paper Publication?]</a:t>
-            </a:r>
-          </a:p>
-          <a:p>
-            <a:pPr lvl="1">
-              <a:lnSpc>
-                <a:spcPct val="150000"/>
-              </a:lnSpc>
-            </a:pPr>
-            <a:r>
-              <a:rPr lang="en-US" sz="1400" b="1" dirty="0">
-                <a:latin typeface="Arial" panose="020B0604020202020204" pitchFamily="34" charset="0"/>
-                <a:cs typeface="Arial" panose="020B0604020202020204" pitchFamily="34" charset="0"/>
-              </a:rPr>
-              <a:t>Slide 8: </a:t>
-            </a:r>
-            <a:r>
-              <a:rPr lang="en-US" sz="1400" dirty="0">
-                <a:latin typeface="Arial" panose="020B0604020202020204" pitchFamily="34" charset="0"/>
-                <a:cs typeface="Arial" panose="020B0604020202020204" pitchFamily="34" charset="0"/>
-              </a:rPr>
-              <a:t>Conclusion:  [Solution Demo URL | New Skills Learned | Any Patent or Publication done? </a:t>
-            </a:r>
-            <a:r>
-              <a:rPr lang="en-US" sz="1400">
-                <a:latin typeface="Arial" panose="020B0604020202020204" pitchFamily="34" charset="0"/>
-                <a:cs typeface="Arial" panose="020B0604020202020204" pitchFamily="34" charset="0"/>
-              </a:rPr>
-              <a:t>…etc.] </a:t>
-            </a:r>
-            <a:endParaRPr lang="en-US" sz="1400" dirty="0">
-              <a:latin typeface="Arial" panose="020B0604020202020204" pitchFamily="34" charset="0"/>
-              <a:cs typeface="Arial" panose="020B0604020202020204" pitchFamily="34" charset="0"/>
-            </a:endParaRPr>
-          </a:p>
-          <a:p>
-            <a:pPr lvl="1">
-              <a:lnSpc>
-                <a:spcPct val="150000"/>
-              </a:lnSpc>
-            </a:pPr>
-            <a:r>
-              <a:rPr lang="en-US" sz="1400" b="1" dirty="0">
-                <a:latin typeface="Arial" panose="020B0604020202020204" pitchFamily="34" charset="0"/>
-                <a:cs typeface="Arial" panose="020B0604020202020204" pitchFamily="34" charset="0"/>
-              </a:rPr>
-              <a:t>Slide 9</a:t>
-            </a:r>
-            <a:r>
-              <a:rPr lang="en-US" sz="1400" dirty="0">
-                <a:latin typeface="Arial" panose="020B0604020202020204" pitchFamily="34" charset="0"/>
-                <a:cs typeface="Arial" panose="020B0604020202020204" pitchFamily="34" charset="0"/>
-              </a:rPr>
-              <a:t>: Thank you! Slide</a:t>
-            </a:r>
-          </a:p>
-          <a:p>
-            <a:pPr lvl="1" algn="ctr">
-              <a:lnSpc>
-                <a:spcPct val="150000"/>
-              </a:lnSpc>
-            </a:pPr>
-            <a:r>
-              <a:rPr lang="en-US" sz="1400" b="1" dirty="0">
-                <a:latin typeface="Arial" panose="020B0604020202020204" pitchFamily="34" charset="0"/>
-                <a:cs typeface="Arial" panose="020B0604020202020204" pitchFamily="34" charset="0"/>
-              </a:rPr>
-              <a:t>USE BULLET POINTS IN SLIDES TO EXPLAIN INSTEAD OF LONG TEXTS OR PARAGRAPHS</a:t>
-            </a:r>
-          </a:p>
-          <a:p>
-            <a:pPr lvl="1" algn="ctr">
-              <a:lnSpc>
-                <a:spcPct val="150000"/>
-              </a:lnSpc>
-            </a:pPr>
-            <a:r>
-              <a:rPr lang="en-US" sz="1600" b="1" u="sng" dirty="0">
-                <a:solidFill>
-                  <a:srgbClr val="FF0000"/>
-                </a:solidFill>
-                <a:latin typeface="Arial" panose="020B0604020202020204" pitchFamily="34" charset="0"/>
-                <a:cs typeface="Arial" panose="020B0604020202020204" pitchFamily="34" charset="0"/>
-              </a:rPr>
-              <a:t>Note</a:t>
-            </a:r>
-            <a:r>
-              <a:rPr lang="en-US" sz="1600" b="1" dirty="0">
-                <a:solidFill>
-                  <a:srgbClr val="FF0000"/>
-                </a:solidFill>
-                <a:latin typeface="Arial" panose="020B0604020202020204" pitchFamily="34" charset="0"/>
-                <a:cs typeface="Arial" panose="020B0604020202020204" pitchFamily="34" charset="0"/>
-              </a:rPr>
-              <a:t>: Please remove this slide in the final presentation. This slide in not in the count!</a:t>
-            </a:r>
-            <a:endParaRPr lang="en-US" b="1" dirty="0">
-              <a:solidFill>
-                <a:srgbClr val="FF0000"/>
-              </a:solidFill>
-              <a:latin typeface="Arial" panose="020B0604020202020204" pitchFamily="34" charset="0"/>
-              <a:cs typeface="Arial" panose="020B0604020202020204" pitchFamily="34" charset="0"/>
-            </a:endParaRPr>
-          </a:p>
-        </p:txBody>
-      </p:sp>
-      <p:sp>
-        <p:nvSpPr>
-          <p:cNvPr id="2" name="TextBox 1">
-            <a:extLst>
-              <a:ext uri="{FF2B5EF4-FFF2-40B4-BE49-F238E27FC236}">
-                <a16:creationId xmlns:a16="http://schemas.microsoft.com/office/drawing/2014/main" id="{9E4F58E0-2E87-351A-4DA8-5D6AF3B8ACF6}"/>
-              </a:ext>
-            </a:extLst>
-          </p:cNvPr>
-          <p:cNvSpPr txBox="1"/>
-          <p:nvPr/>
-        </p:nvSpPr>
-        <p:spPr>
-          <a:xfrm>
-            <a:off x="882944" y="144685"/>
-            <a:ext cx="10426111" cy="400110"/>
-          </a:xfrm>
-          <a:prstGeom prst="rect">
-            <a:avLst/>
-          </a:prstGeom>
-          <a:noFill/>
-        </p:spPr>
-        <p:txBody>
-          <a:bodyPr wrap="square" rtlCol="0">
-            <a:spAutoFit/>
-          </a:bodyPr>
-          <a:lstStyle/>
-          <a:p>
-            <a:pPr marL="0" marR="0" lvl="0" indent="0" algn="l" defTabSz="914400" rtl="0" eaLnBrk="1" fontAlgn="auto" latinLnBrk="0" hangingPunct="1">
-              <a:lnSpc>
-                <a:spcPct val="100000"/>
-              </a:lnSpc>
-              <a:spcBef>
-                <a:spcPts val="0"/>
-              </a:spcBef>
-              <a:spcAft>
-                <a:spcPts val="0"/>
-              </a:spcAft>
-              <a:buClrTx/>
-              <a:buSzTx/>
-              <a:buFontTx/>
-              <a:buNone/>
-              <a:tabLst/>
-              <a:defRPr/>
-            </a:pPr>
-            <a:r>
-              <a:rPr lang="en-IN" sz="2000" b="1" dirty="0">
-                <a:solidFill>
-                  <a:srgbClr val="FF0000"/>
-                </a:solidFill>
-                <a:latin typeface="Arial" panose="020B0604020202020204" pitchFamily="34" charset="0"/>
-                <a:cs typeface="Arial" panose="020B0604020202020204" pitchFamily="34" charset="0"/>
-              </a:rPr>
-              <a:t>PPT Guidelines</a:t>
-            </a:r>
-            <a:endParaRPr kumimoji="0" lang="en-IN" sz="2000" b="1" i="0" u="none" strike="noStrike" kern="1200" cap="none" spc="0" normalizeH="0" baseline="0" noProof="0" dirty="0">
-              <a:ln>
-                <a:noFill/>
-              </a:ln>
-              <a:solidFill>
-                <a:srgbClr val="FF0000"/>
-              </a:solidFill>
-              <a:effectLst/>
-              <a:uLnTx/>
-              <a:uFillTx/>
-              <a:latin typeface="Arial" panose="020B0604020202020204" pitchFamily="34" charset="0"/>
-              <a:cs typeface="Arial" panose="020B0604020202020204" pitchFamily="34" charset="0"/>
-            </a:endParaRPr>
-          </a:p>
-        </p:txBody>
-      </p:sp>
-    </p:spTree>
-    <p:extLst>
-      <p:ext uri="{BB962C8B-B14F-4D97-AF65-F5344CB8AC3E}">
-        <p14:creationId xmlns:p14="http://schemas.microsoft.com/office/powerpoint/2010/main" val="4186805769"/>
-      </p:ext>
-    </p:extLst>
-  </p:cSld>
-  <p:clrMapOvr>
-    <a:masterClrMapping/>
-  </p:clrMapOvr>
-</p:sld>
-</file>
-
 <file path=ppt/slides/slide10.xml><?xml version="1.0" encoding="utf-8"?>
 <p:sld xmlns:a="http://schemas.openxmlformats.org/drawingml/2006/main" xmlns:r="http://schemas.openxmlformats.org/officeDocument/2006/relationships" xmlns:p="http://schemas.openxmlformats.org/presentationml/2006/main">
   <p:cSld>
@@ -9882,7 +9282,7 @@
               </a:defRPr>
             </a:pPr>
             <a:r>
-              <a:t>Team G-1392  |  Department of Computer Science &amp; Engineering  |  KMIT</a:t>
+              <a:t>Team G-1392  |  Department of Computer Science and Engineering (AI&amp;ML)  |  KMIT</a:t>
             </a:r>
           </a:p>
         </p:txBody>
@@ -10195,17 +9595,18 @@
               <a:buNone/>
             </a:pPr>
             <a:r>
+              <a:rPr sz="1300" b="1">
+                <a:solidFill>
+                  <a:srgbClr val="C62828"/>
+                </a:solidFill>
+                <a:latin typeface="Arial"/>
+              </a:rPr>
+              <a:t>KR24_SDC-II_III-I_2026 Project Review-I
+</a:t>
+            </a:r>
+            <a:r>
               <a:rPr sz="2000" b="1">
                 <a:solidFill>
-                  <a:srgbClr val="C62828"/>
-                </a:solidFill>
-                <a:latin typeface="Arial"/>
-              </a:rPr>
-              <a:t>Team G-1392 | </a:t>
-            </a:r>
-            <a:r>
-              <a:rPr sz="2000" b="1">
-                <a:solidFill>
                   <a:srgbClr val="000000"/>
                 </a:solidFill>
                 <a:latin typeface="Arial"/>
@@ -10227,7 +9628,7 @@
                 </a:solidFill>
                 <a:latin typeface="Arial"/>
               </a:rPr>
-              <a:t>(SmartInterview Platform)   |   Date: 23-Sep-2026</a:t>
+              <a:t>(SmartInterview — G-1392)   |   Date: 24-09-2026</a:t>
             </a:r>
           </a:p>
         </p:txBody>
@@ -10516,7 +9917,7 @@
                 <a:spcPts val="200"/>
               </a:spcAft>
               <a:buNone/>
-              <a:defRPr sz="1250">
+              <a:defRPr sz="1200">
                 <a:solidFill>
                   <a:srgbClr val="000000"/>
                 </a:solidFill>
@@ -10533,7 +9934,7 @@
                 <a:spcPts val="200"/>
               </a:spcAft>
               <a:buNone/>
-              <a:defRPr sz="1250">
+              <a:defRPr sz="1200">
                 <a:solidFill>
                   <a:srgbClr val="000000"/>
                 </a:solidFill>
@@ -10541,7 +9942,7 @@
               </a:defRPr>
             </a:pPr>
             <a:r>
-              <a:t>• Vasireddy Vignesh Reddy (24BD1A665X)</a:t>
+              <a:t>• Thodsam Srujan (24BD1A665R)</a:t>
             </a:r>
           </a:p>
           <a:p>
@@ -10550,7 +9951,7 @@
                 <a:spcPts val="200"/>
               </a:spcAft>
               <a:buNone/>
-              <a:defRPr sz="1250">
+              <a:defRPr sz="1200">
                 <a:solidFill>
                   <a:srgbClr val="000000"/>
                 </a:solidFill>
@@ -10558,7 +9959,7 @@
               </a:defRPr>
             </a:pPr>
             <a:r>
-              <a:t>• Thodsam Srujan (24BD1A665R)</a:t>
+              <a:t>• Vasireddy Vignesh Reddy (24BD1A665X)</a:t>
             </a:r>
           </a:p>
           <a:p>
@@ -10567,7 +9968,7 @@
                 <a:spcPts val="200"/>
               </a:spcAft>
               <a:buNone/>
-              <a:defRPr sz="1250">
+              <a:defRPr sz="1200">
                 <a:solidFill>
                   <a:srgbClr val="000000"/>
                 </a:solidFill>
@@ -10584,7 +9985,7 @@
                 <a:spcPts val="200"/>
               </a:spcAft>
               <a:buNone/>
-              <a:defRPr sz="1250">
+              <a:defRPr sz="1200">
                 <a:solidFill>
                   <a:srgbClr val="000000"/>
                 </a:solidFill>
@@ -10878,7 +10279,7 @@
               <a:buNone/>
             </a:pPr>
             <a:r>
-              <a:t>Project Mentor &amp; Institution:</a:t>
+              <a:t>Faculty Mentor:</a:t>
             </a:r>
           </a:p>
           <a:p>
@@ -10889,7 +10290,7 @@
               <a:buNone/>
             </a:pPr>
             <a:r>
-              <a:rPr b="1" sz="1250">
+              <a:rPr b="1" sz="1200">
                 <a:solidFill>
                   <a:srgbClr val="000000"/>
                 </a:solidFill>
@@ -10898,7 +10299,7 @@
               <a:t>• Mentor: </a:t>
             </a:r>
             <a:r>
-              <a:rPr sz="1250">
+              <a:rPr sz="1200">
                 <a:solidFill>
                   <a:srgbClr val="212121"/>
                 </a:solidFill>
@@ -10915,22 +10316,22 @@
               <a:buNone/>
             </a:pPr>
             <a:r>
-              <a:rPr b="1" sz="1250">
+              <a:rPr b="1" sz="1200">
                 <a:solidFill>
                   <a:srgbClr val="000000"/>
                 </a:solidFill>
                 <a:latin typeface="Times New Roman"/>
               </a:rPr>
-              <a:t>• Designation: </a:t>
-            </a:r>
-            <a:r>
-              <a:rPr sz="1250">
+              <a:t>• Department: </a:t>
+            </a:r>
+            <a:r>
+              <a:rPr sz="1200">
                 <a:solidFill>
                   <a:srgbClr val="212121"/>
                 </a:solidFill>
                 <a:latin typeface="Times New Roman"/>
               </a:rPr>
-              <a:t>Professor / Faculty Mentor</a:t>
+              <a:t>Department of Computer Science and Engineering (AI&amp;ML)</a:t>
             </a:r>
           </a:p>
           <a:p>
@@ -10941,74 +10342,22 @@
               <a:buNone/>
             </a:pPr>
             <a:r>
-              <a:rPr b="1" sz="1250">
+              <a:rPr b="1" sz="1200">
                 <a:solidFill>
                   <a:srgbClr val="000000"/>
                 </a:solidFill>
                 <a:latin typeface="Times New Roman"/>
               </a:rPr>
-              <a:t>• Department: </a:t>
-            </a:r>
-            <a:r>
-              <a:rPr sz="1250">
+              <a:t>• Institution: </a:t>
+            </a:r>
+            <a:r>
+              <a:rPr sz="1200">
                 <a:solidFill>
                   <a:srgbClr val="212121"/>
                 </a:solidFill>
                 <a:latin typeface="Times New Roman"/>
               </a:rPr>
-              <a:t>Computer Science &amp; Engineering (CSE)</a:t>
-            </a:r>
-          </a:p>
-          <a:p>
-            <a:pPr>
-              <a:spcAft>
-                <a:spcPts val="200"/>
-              </a:spcAft>
-              <a:buNone/>
-            </a:pPr>
-            <a:r>
-              <a:rPr b="1" sz="1250">
-                <a:solidFill>
-                  <a:srgbClr val="000000"/>
-                </a:solidFill>
-                <a:latin typeface="Times New Roman"/>
-              </a:rPr>
-              <a:t>• Institution: </a:t>
-            </a:r>
-            <a:r>
-              <a:rPr sz="1250">
-                <a:solidFill>
-                  <a:srgbClr val="212121"/>
-                </a:solidFill>
-                <a:latin typeface="Times New Roman"/>
-              </a:rPr>
               <a:t>Keshav Memorial Institute of Technology (KMIT)</a:t>
-            </a:r>
-          </a:p>
-          <a:p>
-            <a:pPr>
-              <a:spcAft>
-                <a:spcPts val="200"/>
-              </a:spcAft>
-              <a:buNone/>
-            </a:pPr>
-            <a:r>
-              <a:rPr b="1" sz="1250">
-                <a:solidFill>
-                  <a:srgbClr val="000000"/>
-                </a:solidFill>
-                <a:latin typeface="Times New Roman"/>
-              </a:rPr>
-              <a:t>• Affiliation: </a:t>
-            </a:r>
-            <a:r>
-              <a:rPr sz="1250">
-                <a:solidFill>
-                  <a:srgbClr val="212121"/>
-                </a:solidFill>
-                <a:latin typeface="Times New Roman"/>
-              </a:rPr>
-              <a:t>Affiliated to JNTUH, Hyderabad</a:t>
             </a:r>
           </a:p>
         </p:txBody>

</xml_diff>